<commit_message>
Updated German Stroop Instructions
</commit_message>
<xml_diff>
--- a/docs/aau.cnap.lnp.cogniPain2.protocol.v2/StroopInstructions_DE.pptx
+++ b/docs/aau.cnap.lnp.cogniPain2.protocol.v2/StroopInstructions_DE.pptx
@@ -200,7 +200,7 @@
           <a:p>
             <a:fld id="{9C9C5307-3CE3-407E-9D60-908EEB969D0F}" type="datetimeFigureOut">
               <a:rPr lang="en-DK" smtClean="0"/>
-              <a:t>26/06/2026</a:t>
+              <a:t>07/16/2026</a:t>
             </a:fld>
             <a:endParaRPr lang="en-DK"/>
           </a:p>
@@ -359,7 +359,7 @@
           <a:p>
             <a:fld id="{B9B591FB-4521-4877-90E0-876AFC35B8BF}" type="slidenum">
               <a:rPr lang="en-DK" smtClean="0"/>
-              <a:t>‹#›</a:t>
+              <a:t>‹Nr.›</a:t>
             </a:fld>
             <a:endParaRPr lang="en-DK"/>
           </a:p>
@@ -2039,7 +2039,7 @@
         <p:spPr>
           <a:xfrm>
             <a:off x="2158618" y="3531718"/>
-            <a:ext cx="1619354" cy="707886"/>
+            <a:ext cx="1447832" cy="707886"/>
           </a:xfrm>
           <a:prstGeom prst="rect">
             <a:avLst/>
@@ -2058,7 +2058,7 @@
                   <a:srgbClr val="FF0000"/>
                 </a:solidFill>
               </a:rPr>
-              <a:t>ZWEIG</a:t>
+              <a:t>GRÜN</a:t>
             </a:r>
             <a:endParaRPr lang="en-DK" sz="4000" dirty="0">
               <a:solidFill>
@@ -3488,7 +3488,7 @@
         <p:spPr>
           <a:xfrm>
             <a:off x="2158618" y="3531718"/>
-            <a:ext cx="1619354" cy="707886"/>
+            <a:ext cx="1447832" cy="707886"/>
           </a:xfrm>
           <a:prstGeom prst="rect">
             <a:avLst/>
@@ -3502,12 +3502,12 @@
           <a:lstStyle/>
           <a:p>
             <a:r>
-              <a:rPr lang="en-GB" sz="4000" dirty="0">
+              <a:rPr lang="en-GB" sz="4000">
                 <a:solidFill>
                   <a:srgbClr val="FF0000"/>
                 </a:solidFill>
               </a:rPr>
-              <a:t>ZWEIG</a:t>
+              <a:t>GRÜN</a:t>
             </a:r>
             <a:endParaRPr lang="en-DK" sz="4000" dirty="0">
               <a:solidFill>

</xml_diff>